<commit_message>
docs(saturdays-ai): credit the full team on the DemoDay deliverables
Francisco Higuera (Docente de Programación), Cristian Guillermo (Docente
de Machine Learning) and José Francisco Silva (Director de la Carrera
Tecnología en Desarrollo de Software), all Unidad Académica Especializada
en la Formación Técnica y Tecnológica.
</commit_message>
<xml_diff>
--- a/docs/saturdays_ai/DemoDaySaturdaysAI_HybridRetrieval_Presentacion.pptx
+++ b/docs/saturdays_ai/DemoDaySaturdaysAI_HybridRetrieval_Presentacion.pptx
@@ -2602,8 +2602,8 @@
         </p:nvSpPr>
         <p:spPr>
           <a:xfrm>
-            <a:off x="822960" y="6126480"/>
-            <a:ext cx="10058400" cy="365760"/>
+            <a:off x="822960" y="5577840"/>
+            <a:ext cx="10058400" cy="914400"/>
           </a:xfrm>
           <a:prstGeom prst="rect">
             <a:avLst/>
@@ -2627,9 +2627,27 @@
                 <a:ea typeface="Calibri" pitchFamily="34" charset="-122"/>
                 <a:cs typeface="Calibri" pitchFamily="34" charset="-120"/>
               </a:rPr>
-              <a:t>Francisco Javier Higuera González  ·  Universidad UTE  ·  francisco.higuera@ute.edu.ec</a:t>
-            </a:r>
-            <a:endParaRPr lang="en-US" sz="1200" dirty="0"/>
+              <a:t>Francisco Javier Higuera González  ·  Cristian Guillermo  ·  José Francisco Silva</a:t>
+            </a:r>
+          </a:p>
+          <a:p>
+            <a:pPr indent="0" marL="0">
+              <a:spcBef>
+                <a:spcPts val="400"/>
+              </a:spcBef>
+              <a:buNone/>
+            </a:pPr>
+            <a:r>
+              <a:rPr lang="en-US" sz="1200" dirty="0">
+                <a:solidFill>
+                  <a:srgbClr val="67728F"/>
+                </a:solidFill>
+                <a:latin typeface="Calibri" pitchFamily="34" charset="0"/>
+                <a:ea typeface="Calibri" pitchFamily="34" charset="-122"/>
+                <a:cs typeface="Calibri" pitchFamily="34" charset="-120"/>
+              </a:rPr>
+              <a:t>Unidad Académica Especializada en la Formación Técnica y Tecnológica  ·  Universidad UTE  ·  francisco.higuera@ute.edu.ec</a:t>
+            </a:r>
           </a:p>
         </p:txBody>
       </p:sp>

</xml_diff>

<commit_message>
docs(saturdays-ai): fill in the real evaluation result (15/15 RAG vs 0/15 baseline)
Official POST /api/rag/evaluation/run against production (896 embeddings
reloaded with the E5 prefix fix, real vLLM + TEI), persisted in
rag_evaluation_runs and visible live on the Evaluación screen. Replaces
every "pendiente" placeholder in both the report and the deck with the
real figure, plus a qualitative example contrasting a hallucinated
baseline answer against the grounded RAG citation.
</commit_message>
<xml_diff>
--- a/docs/saturdays_ai/DemoDaySaturdaysAI_HybridRetrieval_Presentacion.pptx
+++ b/docs/saturdays_ai/DemoDaySaturdaysAI_HybridRetrieval_Presentacion.pptx
@@ -3077,7 +3077,7 @@
                 <a:ea typeface="Calibri" pitchFamily="34" charset="-122"/>
                 <a:cs typeface="Calibri" pitchFamily="34" charset="-120"/>
               </a:rPr>
-              <a:t>• Cifra de aciertos RAG real pendiente de la corrida final en producción.</a:t>
+              <a:t>• Falta validar el checklist con retroalimentación de coordinadores de carrera reales (15/15 mide recuperación, no acuerdo humano-IA).</a:t>
             </a:r>
             <a:endParaRPr lang="en-US" sz="1200" dirty="0"/>
           </a:p>
@@ -9460,7 +9460,7 @@
                 <a:ea typeface="Calibri" pitchFamily="34" charset="-122"/>
                 <a:cs typeface="Calibri" pitchFamily="34" charset="-120"/>
               </a:rPr>
-              <a:t>Pendiente — corrida final en producción con embeddings reales (HPC) recalculados tras el fix de prefijos</a:t>
+              <a:t>15/15 (100%) con RAG, 0/15 con baseline — corrida oficial en producción, 11 de octubre de 2026</a:t>
             </a:r>
             <a:endParaRPr lang="en-US" sz="1300" dirty="0"/>
           </a:p>

</xml_diff>

<commit_message>
docs(saturdays-ai): reflect 14B/2-GPU HPC architecture in deliverables, add demo questions
Updates the informe and presentacion with the AI Tutor's HPC connection,
the 14B text model upgrade, and the new chat de normativa screen — all
previously only in the plan log. Adds a step-by-step RAG mechanism
explanation to the informe, and a new doc with example demo questions
tested live in production.
</commit_message>
<xml_diff>
--- a/docs/saturdays_ai/DemoDaySaturdaysAI_HybridRetrieval_Presentacion.pptx
+++ b/docs/saturdays_ai/DemoDaySaturdaysAI_HybridRetrieval_Presentacion.pptx
@@ -6591,7 +6591,7 @@
                 <a:ea typeface="Calibri" pitchFamily="34" charset="-122"/>
                 <a:cs typeface="Calibri" pitchFamily="34" charset="-120"/>
               </a:rPr>
-              <a:t>inverso ×2</a:t>
+              <a:t>inverso ×3</a:t>
             </a:r>
             <a:endParaRPr lang="en-US" sz="1100" dirty="0"/>
           </a:p>
@@ -6753,7 +6753,7 @@
                 <a:ea typeface="Cambria" pitchFamily="34" charset="-122"/>
                 <a:cs typeface="Cambria" pitchFamily="34" charset="-120"/>
               </a:rPr>
-              <a:t>vLLM · Qwen2.5-7B-Instruct</a:t>
+              <a:t>vLLM · Qwen2.5-14B-Instruct</a:t>
             </a:r>
             <a:endParaRPr lang="en-US" sz="1300" dirty="0"/>
           </a:p>
@@ -6931,7 +6931,7 @@
                 <a:ea typeface="Calibri" pitchFamily="34" charset="-122"/>
                 <a:cs typeface="Calibri" pitchFamily="34" charset="-120"/>
               </a:rPr>
-              <a:t>1 sola reserva Slurm compartida (límite de la cuenta: 1 job concurrente) — se libera al terminar, costo GPU = 0 el resto del tiempo</a:t>
+              <a:t>2 GPUs dedicadas en 1 sola reserva Slurm (mismo nodo): RAG (vLLM texto 14B) + Tutor IA (vLLM visión 7B) — se liberan al terminar, costo = 0 el resto del tiempo</a:t>
             </a:r>
             <a:endParaRPr lang="en-US" sz="1000" dirty="0"/>
           </a:p>
@@ -8244,7 +8244,7 @@
                           <a:ea typeface="Calibri" pitchFamily="34" charset="-122"/>
                           <a:cs typeface="Calibri" pitchFamily="34" charset="-120"/>
                         </a:rPr>
-                        <a:t>Qwen/Qwen2.5-7B-Instruct</a:t>
+                        <a:t>Qwen/Qwen2.5-14B-Instruct</a:t>
                       </a:r>
                       <a:endParaRPr lang="en-US" sz="1400" dirty="0">
                         <a:latin typeface="Calibri" charset="0"/>
@@ -8680,7 +8680,7 @@
                 <a:ea typeface="Calibri" pitchFamily="34" charset="-122"/>
                 <a:cs typeface="Calibri" pitchFamily="34" charset="-120"/>
               </a:rPr>
-              <a:t>El volumen no exige un vector store dedicado, pero se eligió uno (embebido, más liviano que Chroma) para demostrar el componente de IA. BM25 se sumó para no perder un artículo que comparte una palabra exacta con la consulta pero que el embedding no ubica entre los más similares.</a:t>
+              <a:t>El volumen no exige un vector store dedicado, pero se eligió uno (embebido, más liviano que Chroma) para demostrar el componente de IA. BM25 se sumó para no perder un artículo que comparte una palabra exacta con la consulta pero que el embedding no ubica entre los más similares. El Tutor IA (pistas e imágenes) usa un modelo de visión aparte (Qwen2.5-VL-7B-Instruct) en una segunda GPU — no pasa por esta recuperación.</a:t>
             </a:r>
             <a:endParaRPr lang="en-US" sz="1200" dirty="0"/>
           </a:p>
@@ -8960,7 +8960,7 @@
                 <a:ea typeface="Cambria" pitchFamily="34" charset="-122"/>
                 <a:cs typeface="Cambria" pitchFamily="34" charset="-120"/>
               </a:rPr>
-              <a:t>118</a:t>
+              <a:t>130</a:t>
             </a:r>
             <a:endParaRPr lang="en-US" sz="4800" dirty="0"/>
           </a:p>
@@ -9116,7 +9116,7 @@
                 <a:ea typeface="Cambria" pitchFamily="34" charset="-122"/>
                 <a:cs typeface="Cambria" pitchFamily="34" charset="-120"/>
               </a:rPr>
-              <a:t>372</a:t>
+              <a:t>394</a:t>
             </a:r>
             <a:endParaRPr lang="en-US" sz="4800" dirty="0"/>
           </a:p>

</xml_diff>